<commit_message>
Fix Executive Sponsorship Deck: remove duplicate effectLst so the Office web viewer can open it
Each shadowed card had two <a:effectLst> elements (an empty one from
disabling inherited shadow, then the real drop shadow). Two effect lists in
one spPr is invalid OOXML: lenient tools opened it, but the strict Office
web viewer rejected the file ("Can't view or download a copy"). Rebuilt so
each shape has exactly one effectLst. Shadows and layout unchanged.

Co-authored-by: Copilot <223556219+Copilot@users.noreply.github.com>
</commit_message>
<xml_diff>
--- a/education playground/assets/executive copilot playbook/Copilot-Premium-Executive-Sponsorship.pptx
+++ b/education playground/assets/executive copilot playbook/Copilot-Premium-Executive-Sponsorship.pptx
@@ -7305,7 +7305,6 @@
           <a:ln>
             <a:noFill/>
           </a:ln>
-          <a:effectLst/>
           <a:effectLst>
             <a:outerShdw blurRad="91440" dist="45720" dir="5400000" rotWithShape="0">
               <a:srgbClr val="12204A">
@@ -7642,7 +7641,6 @@
           <a:ln>
             <a:noFill/>
           </a:ln>
-          <a:effectLst/>
           <a:effectLst>
             <a:outerShdw blurRad="91440" dist="45720" dir="5400000" rotWithShape="0">
               <a:srgbClr val="12204A">
@@ -7979,7 +7977,6 @@
           <a:ln>
             <a:noFill/>
           </a:ln>
-          <a:effectLst/>
           <a:effectLst>
             <a:outerShdw blurRad="91440" dist="45720" dir="5400000" rotWithShape="0">
               <a:srgbClr val="12204A">
@@ -8316,7 +8313,6 @@
           <a:ln>
             <a:noFill/>
           </a:ln>
-          <a:effectLst/>
           <a:effectLst>
             <a:outerShdw blurRad="91440" dist="45720" dir="5400000" rotWithShape="0">
               <a:srgbClr val="12204A">
@@ -12221,7 +12217,6 @@
           <a:ln>
             <a:noFill/>
           </a:ln>
-          <a:effectLst/>
           <a:effectLst>
             <a:outerShdw blurRad="91440" dist="45720" dir="5400000" rotWithShape="0">
               <a:srgbClr val="12204A">
@@ -12469,7 +12464,6 @@
           <a:ln>
             <a:noFill/>
           </a:ln>
-          <a:effectLst/>
           <a:effectLst>
             <a:outerShdw blurRad="91440" dist="45720" dir="5400000" rotWithShape="0">
               <a:srgbClr val="12204A">
@@ -12717,7 +12711,6 @@
           <a:ln>
             <a:noFill/>
           </a:ln>
-          <a:effectLst/>
           <a:effectLst>
             <a:outerShdw blurRad="91440" dist="45720" dir="5400000" rotWithShape="0">
               <a:srgbClr val="12204A">
@@ -13395,7 +13388,6 @@
           <a:ln>
             <a:noFill/>
           </a:ln>
-          <a:effectLst/>
           <a:effectLst>
             <a:outerShdw blurRad="91440" dist="45720" dir="5400000" rotWithShape="0">
               <a:srgbClr val="12204A">
@@ -13599,7 +13591,6 @@
           <a:ln>
             <a:noFill/>
           </a:ln>
-          <a:effectLst/>
           <a:effectLst>
             <a:outerShdw blurRad="91440" dist="45720" dir="5400000" rotWithShape="0">
               <a:srgbClr val="12204A">
@@ -13803,7 +13794,6 @@
           <a:ln>
             <a:noFill/>
           </a:ln>
-          <a:effectLst/>
           <a:effectLst>
             <a:outerShdw blurRad="91440" dist="45720" dir="5400000" rotWithShape="0">
               <a:srgbClr val="12204A">
@@ -14007,7 +13997,6 @@
           <a:ln>
             <a:noFill/>
           </a:ln>
-          <a:effectLst/>
           <a:effectLst>
             <a:outerShdw blurRad="91440" dist="45720" dir="5400000" rotWithShape="0">
               <a:srgbClr val="12204A">
@@ -14488,7 +14477,6 @@
           <a:ln>
             <a:noFill/>
           </a:ln>
-          <a:effectLst/>
           <a:effectLst>
             <a:outerShdw blurRad="91440" dist="45720" dir="5400000" rotWithShape="0">
               <a:srgbClr val="12204A">
@@ -14665,7 +14653,6 @@
           <a:ln>
             <a:noFill/>
           </a:ln>
-          <a:effectLst/>
           <a:effectLst>
             <a:outerShdw blurRad="91440" dist="45720" dir="5400000" rotWithShape="0">
               <a:srgbClr val="12204A">
@@ -14842,7 +14829,6 @@
           <a:ln>
             <a:noFill/>
           </a:ln>
-          <a:effectLst/>
           <a:effectLst>
             <a:outerShdw blurRad="91440" dist="45720" dir="5400000" rotWithShape="0">
               <a:srgbClr val="12204A">
@@ -15019,7 +15005,6 @@
           <a:ln>
             <a:noFill/>
           </a:ln>
-          <a:effectLst/>
           <a:effectLst>
             <a:outerShdw blurRad="91440" dist="45720" dir="5400000" rotWithShape="0">
               <a:srgbClr val="12204A">
@@ -15196,7 +15181,6 @@
           <a:ln>
             <a:noFill/>
           </a:ln>
-          <a:effectLst/>
           <a:effectLst>
             <a:outerShdw blurRad="91440" dist="45720" dir="5400000" rotWithShape="0">
               <a:srgbClr val="12204A">
@@ -15416,7 +15400,6 @@
           <a:ln>
             <a:noFill/>
           </a:ln>
-          <a:effectLst/>
           <a:effectLst>
             <a:outerShdw blurRad="91440" dist="45720" dir="5400000" rotWithShape="0">
               <a:srgbClr val="12204A">
@@ -15636,7 +15619,6 @@
           <a:ln>
             <a:noFill/>
           </a:ln>
-          <a:effectLst/>
           <a:effectLst>
             <a:outerShdw blurRad="91440" dist="45720" dir="5400000" rotWithShape="0">
               <a:srgbClr val="12204A">
@@ -16090,7 +16072,6 @@
           <a:ln>
             <a:noFill/>
           </a:ln>
-          <a:effectLst/>
           <a:effectLst>
             <a:outerShdw blurRad="91440" dist="45720" dir="5400000" rotWithShape="0">
               <a:srgbClr val="12204A">
@@ -16775,7 +16756,6 @@
           <a:ln>
             <a:noFill/>
           </a:ln>
-          <a:effectLst/>
           <a:effectLst>
             <a:outerShdw blurRad="91440" dist="45720" dir="5400000" rotWithShape="0">
               <a:srgbClr val="12204A">
@@ -17268,7 +17248,6 @@
           <a:ln>
             <a:noFill/>
           </a:ln>
-          <a:effectLst/>
           <a:effectLst>
             <a:outerShdw blurRad="91440" dist="45720" dir="5400000" rotWithShape="0">
               <a:srgbClr val="12204A">
@@ -19390,7 +19369,6 @@
           <a:ln>
             <a:noFill/>
           </a:ln>
-          <a:effectLst/>
           <a:effectLst>
             <a:outerShdw blurRad="91440" dist="45720" dir="5400000" rotWithShape="0">
               <a:srgbClr val="12204A">
@@ -19747,7 +19725,6 @@
           <a:ln>
             <a:noFill/>
           </a:ln>
-          <a:effectLst/>
           <a:effectLst>
             <a:outerShdw blurRad="91440" dist="45720" dir="5400000" rotWithShape="0">
               <a:srgbClr val="12204A">
@@ -20104,7 +20081,6 @@
           <a:ln>
             <a:noFill/>
           </a:ln>
-          <a:effectLst/>
           <a:effectLst>
             <a:outerShdw blurRad="91440" dist="45720" dir="5400000" rotWithShape="0">
               <a:srgbClr val="12204A">
@@ -20787,7 +20763,6 @@
           <a:ln>
             <a:noFill/>
           </a:ln>
-          <a:effectLst/>
           <a:effectLst>
             <a:outerShdw blurRad="91440" dist="45720" dir="5400000" rotWithShape="0">
               <a:srgbClr val="12204A">
@@ -21035,7 +21010,6 @@
           <a:ln>
             <a:noFill/>
           </a:ln>
-          <a:effectLst/>
           <a:effectLst>
             <a:outerShdw blurRad="91440" dist="45720" dir="5400000" rotWithShape="0">
               <a:srgbClr val="12204A">
@@ -21283,7 +21257,6 @@
           <a:ln>
             <a:noFill/>
           </a:ln>
-          <a:effectLst/>
           <a:effectLst>
             <a:outerShdw blurRad="91440" dist="45720" dir="5400000" rotWithShape="0">
               <a:srgbClr val="12204A">
@@ -21531,7 +21504,6 @@
           <a:ln>
             <a:noFill/>
           </a:ln>
-          <a:effectLst/>
           <a:effectLst>
             <a:outerShdw blurRad="91440" dist="45720" dir="5400000" rotWithShape="0">
               <a:srgbClr val="12204A">
@@ -21779,7 +21751,6 @@
           <a:ln>
             <a:noFill/>
           </a:ln>
-          <a:effectLst/>
           <a:effectLst>
             <a:outerShdw blurRad="91440" dist="45720" dir="5400000" rotWithShape="0">
               <a:srgbClr val="12204A">
@@ -22027,7 +21998,6 @@
           <a:ln>
             <a:noFill/>
           </a:ln>
-          <a:effectLst/>
           <a:effectLst>
             <a:outerShdw blurRad="91440" dist="45720" dir="5400000" rotWithShape="0">
               <a:srgbClr val="12204A">

</xml_diff>

<commit_message>
Clarify Executive Sponsorship Deck slide 10 (measurement)
Decode the 11 x 11 tipping point (11 min a day x 11 weeks) and add a source
line naming where the metrics come from: the Microsoft 365 Copilot Dashboard
in Viva Insights plus admin usage reports. Updates the PPTX, PDF, and notes.

Co-authored-by: Copilot <223556219+Copilot@users.noreply.github.com>
</commit_message>
<xml_diff>
--- a/education playground/assets/executive copilot playbook/Copilot-Premium-Executive-Sponsorship.pptx
+++ b/education playground/assets/executive copilot playbook/Copilot-Premium-Executive-Sponsorship.pptx
@@ -594,17 +594,17 @@
           <a:lstStyle/>
           <a:p>
             <a:r>
-              <a:t>PURPOSE: Show how you will prove the return, and set a realistic expectation.</a:t>
-            </a:r>
-          </a:p>
-          <a:p>
-            <a:r>
-              <a:t>SAY: "Here is how we will know it is working. Four numbers in a monthly review. Active users, returning users, assisted hours, and satisfaction. Watch the returning users most, because the habit is the real ROI. And one honest expectation. The research points to an eleven by eleven tipping point, about eleven minutes saved a day over eleven weeks before the signal is clear. So give it runway. Do not grade the ROI in the first thirty days."</a:t>
-            </a:r>
-          </a:p>
-          <a:p>
-            <a:r>
-              <a:t>TIP: Setting a realistic bar builds credibility. It signals you are managing this like an investment, not a fad.</a:t>
+              <a:t>PURPOSE: Show how you will prove the return, name where the numbers come from, and set a realistic expectation.</a:t>
+            </a:r>
+          </a:p>
+          <a:p>
+            <a:r>
+              <a:t>SAY: "Here is how we will know it is working. Four numbers in a monthly review, and they come from tools we already own: the Microsoft 365 Copilot Dashboard in Viva Insights, plus the admin usage reports. Active users, returning users, assisted hours, and satisfaction. Watch the returning users most, because the habit is the real ROI. And one honest expectation: the research points to an eleven by eleven tipping point, about eleven minutes saved a day over eleven weeks of steady use before the signal is clear. So give it runway, and do not grade the ROI in the first thirty days."</a:t>
+            </a:r>
+          </a:p>
+          <a:p>
+            <a:r>
+              <a:t>TIP: The first three numbers come straight from the Copilot Dashboard and the admin usage reports. Satisfaction is best captured with a short pulse survey, like Viva Pulse or a simple form. Setting a realistic bar here builds credibility, it signals you are managing this like an investment, not a fad.</a:t>
             </a:r>
           </a:p>
         </p:txBody>
@@ -5742,7 +5742,7 @@
         </p:nvSpPr>
         <p:spPr>
           <a:xfrm>
-            <a:off x="804672" y="896112"/>
+            <a:off x="804672" y="859536"/>
             <a:ext cx="10972800" cy="1371600"/>
           </a:xfrm>
           <a:prstGeom prst="rect">
@@ -5785,8 +5785,8 @@
         </p:nvSpPr>
         <p:spPr>
           <a:xfrm>
-            <a:off x="822960" y="1572768"/>
-            <a:ext cx="10241280" cy="457200"/>
+            <a:off x="822960" y="1463040"/>
+            <a:ext cx="10424160" cy="457200"/>
           </a:xfrm>
           <a:prstGeom prst="rect">
             <a:avLst/>
@@ -5812,7 +5812,7 @@
                 </a:solidFill>
                 <a:latin typeface="Aptos"/>
               </a:rPr>
-              <a:t>Four numbers in a monthly leadership review tell us if the investment is landing.</a:t>
+              <a:t>Four numbers in a monthly leadership review, pulled from tools we already own.</a:t>
             </a:r>
           </a:p>
         </p:txBody>
@@ -5825,8 +5825,8 @@
         </p:nvSpPr>
         <p:spPr>
           <a:xfrm>
-            <a:off x="822960" y="2231136"/>
-            <a:ext cx="2587752" cy="1517904"/>
+            <a:off x="822960" y="2029968"/>
+            <a:ext cx="2587752" cy="1371600"/>
           </a:xfrm>
           <a:prstGeom prst="roundRect">
             <a:avLst>
@@ -5873,8 +5873,8 @@
         </p:nvSpPr>
         <p:spPr>
           <a:xfrm>
-            <a:off x="1833372" y="2450591"/>
-            <a:ext cx="566928" cy="566928"/>
+            <a:off x="1842516" y="2212848"/>
+            <a:ext cx="548640" cy="548640"/>
           </a:xfrm>
           <a:prstGeom prst="ellipse">
             <a:avLst/>
@@ -5925,8 +5925,8 @@
         </p:blipFill>
         <p:spPr>
           <a:xfrm>
-            <a:off x="1969434" y="2586654"/>
-            <a:ext cx="294802" cy="294802"/>
+            <a:off x="1974189" y="2344521"/>
+            <a:ext cx="285292" cy="285292"/>
           </a:xfrm>
           <a:prstGeom prst="rect">
             <a:avLst/>
@@ -5941,7 +5941,7 @@
         </p:nvSpPr>
         <p:spPr>
           <a:xfrm>
-            <a:off x="822960" y="3108960"/>
+            <a:off x="822960" y="2816352"/>
             <a:ext cx="2587752" cy="329184"/>
           </a:xfrm>
           <a:prstGeom prst="rect">
@@ -5981,7 +5981,7 @@
         </p:nvSpPr>
         <p:spPr>
           <a:xfrm>
-            <a:off x="822960" y="3419856"/>
+            <a:off x="822960" y="3090672"/>
             <a:ext cx="2587752" cy="274320"/>
           </a:xfrm>
           <a:prstGeom prst="rect">
@@ -6021,8 +6021,8 @@
         </p:nvSpPr>
         <p:spPr>
           <a:xfrm>
-            <a:off x="3575304" y="2231136"/>
-            <a:ext cx="2587752" cy="1517904"/>
+            <a:off x="3575304" y="2029968"/>
+            <a:ext cx="2587752" cy="1371600"/>
           </a:xfrm>
           <a:prstGeom prst="roundRect">
             <a:avLst>
@@ -6069,8 +6069,8 @@
         </p:nvSpPr>
         <p:spPr>
           <a:xfrm>
-            <a:off x="4585716" y="2450591"/>
-            <a:ext cx="566928" cy="566928"/>
+            <a:off x="4594860" y="2212848"/>
+            <a:ext cx="548640" cy="548640"/>
           </a:xfrm>
           <a:prstGeom prst="ellipse">
             <a:avLst/>
@@ -6121,8 +6121,8 @@
         </p:blipFill>
         <p:spPr>
           <a:xfrm>
-            <a:off x="4721778" y="2586654"/>
-            <a:ext cx="294802" cy="294802"/>
+            <a:off x="4726533" y="2344521"/>
+            <a:ext cx="285292" cy="285292"/>
           </a:xfrm>
           <a:prstGeom prst="rect">
             <a:avLst/>
@@ -6137,7 +6137,7 @@
         </p:nvSpPr>
         <p:spPr>
           <a:xfrm>
-            <a:off x="3575304" y="3108960"/>
+            <a:off x="3575304" y="2816352"/>
             <a:ext cx="2587752" cy="329184"/>
           </a:xfrm>
           <a:prstGeom prst="rect">
@@ -6177,7 +6177,7 @@
         </p:nvSpPr>
         <p:spPr>
           <a:xfrm>
-            <a:off x="3575304" y="3419856"/>
+            <a:off x="3575304" y="3090672"/>
             <a:ext cx="2587752" cy="274320"/>
           </a:xfrm>
           <a:prstGeom prst="rect">
@@ -6217,8 +6217,8 @@
         </p:nvSpPr>
         <p:spPr>
           <a:xfrm>
-            <a:off x="6327648" y="2231136"/>
-            <a:ext cx="2587752" cy="1517904"/>
+            <a:off x="6327648" y="2029968"/>
+            <a:ext cx="2587752" cy="1371600"/>
           </a:xfrm>
           <a:prstGeom prst="roundRect">
             <a:avLst>
@@ -6265,8 +6265,8 @@
         </p:nvSpPr>
         <p:spPr>
           <a:xfrm>
-            <a:off x="7338060" y="2450591"/>
-            <a:ext cx="566928" cy="566928"/>
+            <a:off x="7347204" y="2212848"/>
+            <a:ext cx="548640" cy="548640"/>
           </a:xfrm>
           <a:prstGeom prst="ellipse">
             <a:avLst/>
@@ -6317,8 +6317,8 @@
         </p:blipFill>
         <p:spPr>
           <a:xfrm>
-            <a:off x="7474122" y="2586654"/>
-            <a:ext cx="294802" cy="294802"/>
+            <a:off x="7478877" y="2344521"/>
+            <a:ext cx="285292" cy="285292"/>
           </a:xfrm>
           <a:prstGeom prst="rect">
             <a:avLst/>
@@ -6333,7 +6333,7 @@
         </p:nvSpPr>
         <p:spPr>
           <a:xfrm>
-            <a:off x="6327648" y="3108960"/>
+            <a:off x="6327648" y="2816352"/>
             <a:ext cx="2587752" cy="329184"/>
           </a:xfrm>
           <a:prstGeom prst="rect">
@@ -6373,7 +6373,7 @@
         </p:nvSpPr>
         <p:spPr>
           <a:xfrm>
-            <a:off x="6327648" y="3419856"/>
+            <a:off x="6327648" y="3090672"/>
             <a:ext cx="2587752" cy="274320"/>
           </a:xfrm>
           <a:prstGeom prst="rect">
@@ -6413,8 +6413,8 @@
         </p:nvSpPr>
         <p:spPr>
           <a:xfrm>
-            <a:off x="9079992" y="2231136"/>
-            <a:ext cx="2587752" cy="1517904"/>
+            <a:off x="9079992" y="2029968"/>
+            <a:ext cx="2587752" cy="1371600"/>
           </a:xfrm>
           <a:prstGeom prst="roundRect">
             <a:avLst>
@@ -6461,8 +6461,8 @@
         </p:nvSpPr>
         <p:spPr>
           <a:xfrm>
-            <a:off x="10090404" y="2450591"/>
-            <a:ext cx="566928" cy="566928"/>
+            <a:off x="10099548" y="2212848"/>
+            <a:ext cx="548640" cy="548640"/>
           </a:xfrm>
           <a:prstGeom prst="ellipse">
             <a:avLst/>
@@ -6513,8 +6513,8 @@
         </p:blipFill>
         <p:spPr>
           <a:xfrm>
-            <a:off x="10226466" y="2586654"/>
-            <a:ext cx="294802" cy="294802"/>
+            <a:off x="10231221" y="2344521"/>
+            <a:ext cx="285292" cy="285292"/>
           </a:xfrm>
           <a:prstGeom prst="rect">
             <a:avLst/>
@@ -6529,7 +6529,7 @@
         </p:nvSpPr>
         <p:spPr>
           <a:xfrm>
-            <a:off x="9079992" y="3108960"/>
+            <a:off x="9079992" y="2816352"/>
             <a:ext cx="2587752" cy="329184"/>
           </a:xfrm>
           <a:prstGeom prst="rect">
@@ -6569,7 +6569,7 @@
         </p:nvSpPr>
         <p:spPr>
           <a:xfrm>
-            <a:off x="9079992" y="3419856"/>
+            <a:off x="9079992" y="3090672"/>
             <a:ext cx="2587752" cy="274320"/>
           </a:xfrm>
           <a:prstGeom prst="rect">
@@ -6609,8 +6609,173 @@
         </p:nvSpPr>
         <p:spPr>
           <a:xfrm>
-            <a:off x="822960" y="4114800"/>
-            <a:ext cx="10543032" cy="1133856"/>
+            <a:off x="822960" y="3566160"/>
+            <a:ext cx="10543032" cy="548640"/>
+          </a:xfrm>
+          <a:prstGeom prst="roundRect">
+            <a:avLst>
+              <a:gd name="adj" fmla="val 12000"/>
+            </a:avLst>
+          </a:prstGeom>
+          <a:solidFill>
+            <a:srgbClr val="1B2A55"/>
+          </a:solidFill>
+          <a:ln w="12700">
+            <a:solidFill>
+              <a:srgbClr val="2C3B69"/>
+            </a:solidFill>
+          </a:ln>
+          <a:effectLst/>
+        </p:spPr>
+        <p:style>
+          <a:lnRef idx="1">
+            <a:schemeClr val="accent1"/>
+          </a:lnRef>
+          <a:fillRef idx="3">
+            <a:schemeClr val="accent1"/>
+          </a:fillRef>
+          <a:effectRef idx="2">
+            <a:schemeClr val="accent1"/>
+          </a:effectRef>
+          <a:fontRef idx="minor">
+            <a:schemeClr val="lt1"/>
+          </a:fontRef>
+        </p:style>
+        <p:txBody>
+          <a:bodyPr rtlCol="0" anchor="ctr"/>
+          <a:lstStyle/>
+          <a:p>
+            <a:pPr algn="ctr"/>
+          </a:p>
+        </p:txBody>
+      </p:sp>
+      <p:sp>
+        <p:nvSpPr>
+          <p:cNvPr id="30" name="Oval 29"/>
+          <p:cNvSpPr/>
+          <p:nvPr/>
+        </p:nvSpPr>
+        <p:spPr>
+          <a:xfrm>
+            <a:off x="1060704" y="3657600"/>
+            <a:ext cx="365760" cy="365760"/>
+          </a:xfrm>
+          <a:prstGeom prst="ellipse">
+            <a:avLst/>
+          </a:prstGeom>
+          <a:solidFill>
+            <a:srgbClr val="12B3C4"/>
+          </a:solidFill>
+          <a:ln>
+            <a:noFill/>
+          </a:ln>
+          <a:effectLst/>
+        </p:spPr>
+        <p:style>
+          <a:lnRef idx="1">
+            <a:schemeClr val="accent1"/>
+          </a:lnRef>
+          <a:fillRef idx="3">
+            <a:schemeClr val="accent1"/>
+          </a:fillRef>
+          <a:effectRef idx="2">
+            <a:schemeClr val="accent1"/>
+          </a:effectRef>
+          <a:fontRef idx="minor">
+            <a:schemeClr val="lt1"/>
+          </a:fontRef>
+        </p:style>
+        <p:txBody>
+          <a:bodyPr rtlCol="0" anchor="ctr"/>
+          <a:lstStyle/>
+          <a:p>
+            <a:pPr algn="ctr"/>
+          </a:p>
+        </p:txBody>
+      </p:sp>
+      <p:pic>
+        <p:nvPicPr>
+          <p:cNvPr id="31" name="Picture 30" descr="chart.png"/>
+          <p:cNvPicPr>
+            <a:picLocks noChangeAspect="1"/>
+          </p:cNvPicPr>
+          <p:nvPr/>
+        </p:nvPicPr>
+        <p:blipFill>
+          <a:blip r:embed="rId6"/>
+          <a:stretch>
+            <a:fillRect/>
+          </a:stretch>
+        </p:blipFill>
+        <p:spPr>
+          <a:xfrm>
+            <a:off x="1148486" y="3745382"/>
+            <a:ext cx="190195" cy="190195"/>
+          </a:xfrm>
+          <a:prstGeom prst="rect">
+            <a:avLst/>
+          </a:prstGeom>
+        </p:spPr>
+      </p:pic>
+      <p:sp>
+        <p:nvSpPr>
+          <p:cNvPr id="32" name="TextBox 31"/>
+          <p:cNvSpPr txBox="1"/>
+          <p:nvPr/>
+        </p:nvSpPr>
+        <p:spPr>
+          <a:xfrm>
+            <a:off x="1591056" y="3566160"/>
+            <a:ext cx="9601200" cy="548640"/>
+          </a:xfrm>
+          <a:prstGeom prst="rect">
+            <a:avLst/>
+          </a:prstGeom>
+          <a:noFill/>
+        </p:spPr>
+        <p:txBody>
+          <a:bodyPr wrap="square" anchor="ctr" lIns="0" rIns="0" tIns="0" bIns="0"/>
+          <a:lstStyle/>
+          <a:p>
+            <a:pPr algn="l">
+              <a:spcBef>
+                <a:spcPts val="0"/>
+              </a:spcBef>
+              <a:spcAft>
+                <a:spcPts val="0"/>
+              </a:spcAft>
+            </a:pPr>
+            <a:r>
+              <a:rPr sz="1150" b="1" i="0">
+                <a:solidFill>
+                  <a:srgbClr val="12B3C4"/>
+                </a:solidFill>
+                <a:latin typeface="Aptos"/>
+              </a:rPr>
+              <a:t>Where these come from:  </a:t>
+            </a:r>
+            <a:r>
+              <a:rPr sz="1150" b="0" i="0">
+                <a:solidFill>
+                  <a:srgbClr val="D7E0F5"/>
+                </a:solidFill>
+                <a:latin typeface="Aptos"/>
+              </a:rPr>
+              <a:t>the Microsoft 365 Copilot Dashboard in Viva Insights, plus the Microsoft 365 admin usage reports.</a:t>
+            </a:r>
+          </a:p>
+        </p:txBody>
+      </p:sp>
+      <p:sp>
+        <p:nvSpPr>
+          <p:cNvPr id="33" name="Rounded Rectangle 32"/>
+          <p:cNvSpPr/>
+          <p:nvPr/>
+        </p:nvSpPr>
+        <p:spPr>
+          <a:xfrm>
+            <a:off x="822960" y="4315968"/>
+            <a:ext cx="10543032" cy="1024128"/>
           </a:xfrm>
           <a:prstGeom prst="roundRect">
             <a:avLst>
@@ -6651,14 +6816,14 @@
       </p:sp>
       <p:sp>
         <p:nvSpPr>
-          <p:cNvPr id="30" name="TextBox 29"/>
+          <p:cNvPr id="34" name="TextBox 33"/>
           <p:cNvSpPr txBox="1"/>
           <p:nvPr/>
         </p:nvSpPr>
         <p:spPr>
           <a:xfrm>
-            <a:off x="1051560" y="4114800"/>
-            <a:ext cx="2103120" cy="1133856"/>
+            <a:off x="914400" y="4315968"/>
+            <a:ext cx="2651760" cy="1024128"/>
           </a:xfrm>
           <a:prstGeom prst="rect">
             <a:avLst/>
@@ -6674,11 +6839,11 @@
                 <a:spcPts val="0"/>
               </a:spcBef>
               <a:spcAft>
-                <a:spcPts val="0"/>
+                <a:spcPts val="300"/>
               </a:spcAft>
             </a:pPr>
             <a:r>
-              <a:rPr sz="3000" b="1" i="0">
+              <a:rPr sz="2600" b="1" i="0">
                 <a:solidFill>
                   <a:srgbClr val="F0A500"/>
                 </a:solidFill>
@@ -6687,18 +6852,37 @@
               <a:t>11 × 11</a:t>
             </a:r>
           </a:p>
-        </p:txBody>
-      </p:sp>
-      <p:sp>
-        <p:nvSpPr>
-          <p:cNvPr id="31" name="Rectangle 30"/>
+          <a:p>
+            <a:pPr algn="ctr">
+              <a:spcBef>
+                <a:spcPts val="0"/>
+              </a:spcBef>
+              <a:spcAft>
+                <a:spcPts val="0"/>
+              </a:spcAft>
+            </a:pPr>
+            <a:r>
+              <a:rPr sz="950" b="0" i="0">
+                <a:solidFill>
+                  <a:srgbClr val="CADCFC"/>
+                </a:solidFill>
+                <a:latin typeface="Aptos"/>
+              </a:rPr>
+              <a:t>11 min a day  ·  11 weeks of use</a:t>
+            </a:r>
+          </a:p>
+        </p:txBody>
+      </p:sp>
+      <p:sp>
+        <p:nvSpPr>
+          <p:cNvPr id="35" name="Rectangle 34"/>
           <p:cNvSpPr/>
           <p:nvPr/>
         </p:nvSpPr>
         <p:spPr>
           <a:xfrm>
-            <a:off x="3337560" y="4334256"/>
-            <a:ext cx="18288" cy="694944"/>
+            <a:off x="3657600" y="4535424"/>
+            <a:ext cx="18288" cy="585216"/>
           </a:xfrm>
           <a:prstGeom prst="rect">
             <a:avLst/>
@@ -6735,14 +6919,14 @@
       </p:sp>
       <p:sp>
         <p:nvSpPr>
-          <p:cNvPr id="32" name="TextBox 31"/>
+          <p:cNvPr id="36" name="TextBox 35"/>
           <p:cNvSpPr txBox="1"/>
           <p:nvPr/>
         </p:nvSpPr>
         <p:spPr>
           <a:xfrm>
-            <a:off x="3566160" y="4224528"/>
-            <a:ext cx="7589520" cy="914400"/>
+            <a:off x="3886200" y="4315968"/>
+            <a:ext cx="7269480" cy="1024128"/>
           </a:xfrm>
           <a:prstGeom prst="rect">
             <a:avLst/>
@@ -6777,21 +6961,21 @@
                 </a:solidFill>
                 <a:latin typeface="Aptos"/>
               </a:rPr>
-              <a:t>about 11 minutes saved a day over 11 weeks of steady use before the productivity signal shows. Give it runway, and don't grade ROI in the first 30 days.</a:t>
-            </a:r>
-          </a:p>
-        </p:txBody>
-      </p:sp>
-      <p:sp>
-        <p:nvSpPr>
-          <p:cNvPr id="33" name="Rounded Rectangle 32"/>
+              <a:t>it takes about that much steady use before the productivity signal is clear. So give it runway, and don't grade ROI in the first 30 days.</a:t>
+            </a:r>
+          </a:p>
+        </p:txBody>
+      </p:sp>
+      <p:sp>
+        <p:nvSpPr>
+          <p:cNvPr id="37" name="Rounded Rectangle 36"/>
           <p:cNvSpPr/>
           <p:nvPr/>
         </p:nvSpPr>
         <p:spPr>
           <a:xfrm>
             <a:off x="822960" y="5541264"/>
-            <a:ext cx="10543032" cy="548640"/>
+            <a:ext cx="10543032" cy="512064"/>
           </a:xfrm>
           <a:prstGeom prst="roundRect">
             <a:avLst>
@@ -6832,14 +7016,14 @@
       </p:sp>
       <p:sp>
         <p:nvSpPr>
-          <p:cNvPr id="34" name="TextBox 33"/>
+          <p:cNvPr id="38" name="TextBox 37"/>
           <p:cNvSpPr txBox="1"/>
           <p:nvPr/>
         </p:nvSpPr>
         <p:spPr>
           <a:xfrm>
             <a:off x="1115568" y="5541264"/>
-            <a:ext cx="9994392" cy="548640"/>
+            <a:ext cx="9994392" cy="512064"/>
           </a:xfrm>
           <a:prstGeom prst="rect">
             <a:avLst/>
@@ -6881,7 +7065,7 @@
       </p:sp>
       <p:sp>
         <p:nvSpPr>
-          <p:cNvPr id="35" name="TextBox 34"/>
+          <p:cNvPr id="39" name="TextBox 38"/>
           <p:cNvSpPr txBox="1"/>
           <p:nvPr/>
         </p:nvSpPr>
@@ -6930,7 +7114,7 @@
       </p:sp>
       <p:sp>
         <p:nvSpPr>
-          <p:cNvPr id="36" name="TextBox 35"/>
+          <p:cNvPr id="40" name="TextBox 39"/>
           <p:cNvSpPr txBox="1"/>
           <p:nvPr/>
         </p:nvSpPr>

</xml_diff>

<commit_message>
Slide 10: explicit source legend mapping each metric to how it is captured
Replace the single source line with a two-part legend: active, returning, and
assisted hours come from the Copilot Dashboard (Viva Insights) plus admin usage
reports; satisfaction comes from a short pulse survey. Align metric cards and
update the PDF and speaker notes.

Co-authored-by: Copilot <223556219+Copilot@users.noreply.github.com>
</commit_message>
<xml_diff>
--- a/education playground/assets/executive copilot playbook/Copilot-Premium-Executive-Sponsorship.pptx
+++ b/education playground/assets/executive copilot playbook/Copilot-Premium-Executive-Sponsorship.pptx
@@ -594,17 +594,17 @@
           <a:lstStyle/>
           <a:p>
             <a:r>
-              <a:t>PURPOSE: Show how you will prove the return, name where the numbers come from, and set a realistic expectation.</a:t>
-            </a:r>
-          </a:p>
-          <a:p>
-            <a:r>
-              <a:t>SAY: "Here is how we will know it is working. Four numbers in a monthly review, and they come from tools we already own: the Microsoft 365 Copilot Dashboard in Viva Insights, plus the admin usage reports. Active users, returning users, assisted hours, and satisfaction. Watch the returning users most, because the habit is the real ROI. And one honest expectation: the research points to an eleven by eleven tipping point, about eleven minutes saved a day over eleven weeks of steady use before the signal is clear. So give it runway, and do not grade the ROI in the first thirty days."</a:t>
-            </a:r>
-          </a:p>
-          <a:p>
-            <a:r>
-              <a:t>TIP: The first three numbers come straight from the Copilot Dashboard and the admin usage reports. Satisfaction is best captured with a short pulse survey, like Viva Pulse or a simple form. Setting a realistic bar here builds credibility, it signals you are managing this like an investment, not a fad.</a:t>
+              <a:t>PURPOSE: Show the four measures, name exactly how each is captured, and set a realistic expectation.</a:t>
+            </a:r>
+          </a:p>
+          <a:p>
+            <a:r>
+              <a:t>SAY: "Four numbers in a monthly review, and here is exactly where each comes from. Active users, returning users, and assisted hours all come from the Microsoft 365 Copilot Dashboard in Viva Insights and the admin usage reports, so there is nothing new to build. Satisfaction comes from a short pulse survey. Watch the returning users most, because the habit is the real ROI. And one honest expectation: the eleven by eleven tipping point, about eleven minutes saved a day over eleven weeks of steady use before the signal is clear. So give it runway, and do not grade ROI in the first thirty days."</a:t>
+            </a:r>
+          </a:p>
+          <a:p>
+            <a:r>
+              <a:t>TIP: Three of the four numbers are already in your tenant through the Copilot Dashboard and admin reports, so they are free to pull. Satisfaction is the only one that needs a light survey. If someone asks who owns this, it is the Center of Excellence from the adoption-engine slide.</a:t>
             </a:r>
           </a:p>
         </p:txBody>
@@ -5785,7 +5785,7 @@
         </p:nvSpPr>
         <p:spPr>
           <a:xfrm>
-            <a:off x="822960" y="1463040"/>
+            <a:off x="822960" y="1499616"/>
             <a:ext cx="10424160" cy="457200"/>
           </a:xfrm>
           <a:prstGeom prst="rect">
@@ -5812,7 +5812,7 @@
                 </a:solidFill>
                 <a:latin typeface="Aptos"/>
               </a:rPr>
-              <a:t>Four numbers in a monthly leadership review, pulled from tools we already own.</a:t>
+              <a:t>Four numbers in a monthly leadership review, and exactly where each one comes from.</a:t>
             </a:r>
           </a:p>
         </p:txBody>
@@ -5825,8 +5825,8 @@
         </p:nvSpPr>
         <p:spPr>
           <a:xfrm>
-            <a:off x="822960" y="2029968"/>
-            <a:ext cx="2587752" cy="1371600"/>
+            <a:off x="822960" y="2103120"/>
+            <a:ext cx="2505456" cy="1417320"/>
           </a:xfrm>
           <a:prstGeom prst="roundRect">
             <a:avLst>
@@ -5873,8 +5873,8 @@
         </p:nvSpPr>
         <p:spPr>
           <a:xfrm>
-            <a:off x="1842516" y="2212848"/>
-            <a:ext cx="548640" cy="548640"/>
+            <a:off x="1792224" y="2322576"/>
+            <a:ext cx="566928" cy="566928"/>
           </a:xfrm>
           <a:prstGeom prst="ellipse">
             <a:avLst/>
@@ -5925,8 +5925,8 @@
         </p:blipFill>
         <p:spPr>
           <a:xfrm>
-            <a:off x="1974189" y="2344521"/>
-            <a:ext cx="285292" cy="285292"/>
+            <a:off x="1928286" y="2458638"/>
+            <a:ext cx="294802" cy="294802"/>
           </a:xfrm>
           <a:prstGeom prst="rect">
             <a:avLst/>
@@ -5941,8 +5941,8 @@
         </p:nvSpPr>
         <p:spPr>
           <a:xfrm>
-            <a:off x="822960" y="2816352"/>
-            <a:ext cx="2587752" cy="329184"/>
+            <a:off x="822960" y="2944368"/>
+            <a:ext cx="2505456" cy="329184"/>
           </a:xfrm>
           <a:prstGeom prst="rect">
             <a:avLst/>
@@ -5981,8 +5981,8 @@
         </p:nvSpPr>
         <p:spPr>
           <a:xfrm>
-            <a:off x="822960" y="3090672"/>
-            <a:ext cx="2587752" cy="274320"/>
+            <a:off x="822960" y="3200400"/>
+            <a:ext cx="2505456" cy="274320"/>
           </a:xfrm>
           <a:prstGeom prst="rect">
             <a:avLst/>
@@ -6021,8 +6021,8 @@
         </p:nvSpPr>
         <p:spPr>
           <a:xfrm>
-            <a:off x="3575304" y="2029968"/>
-            <a:ext cx="2587752" cy="1371600"/>
+            <a:off x="3502152" y="2103120"/>
+            <a:ext cx="2505456" cy="1417320"/>
           </a:xfrm>
           <a:prstGeom prst="roundRect">
             <a:avLst>
@@ -6069,8 +6069,8 @@
         </p:nvSpPr>
         <p:spPr>
           <a:xfrm>
-            <a:off x="4594860" y="2212848"/>
-            <a:ext cx="548640" cy="548640"/>
+            <a:off x="4471416" y="2322576"/>
+            <a:ext cx="566928" cy="566928"/>
           </a:xfrm>
           <a:prstGeom prst="ellipse">
             <a:avLst/>
@@ -6121,8 +6121,8 @@
         </p:blipFill>
         <p:spPr>
           <a:xfrm>
-            <a:off x="4726533" y="2344521"/>
-            <a:ext cx="285292" cy="285292"/>
+            <a:off x="4607478" y="2458638"/>
+            <a:ext cx="294802" cy="294802"/>
           </a:xfrm>
           <a:prstGeom prst="rect">
             <a:avLst/>
@@ -6137,8 +6137,8 @@
         </p:nvSpPr>
         <p:spPr>
           <a:xfrm>
-            <a:off x="3575304" y="2816352"/>
-            <a:ext cx="2587752" cy="329184"/>
+            <a:off x="3502152" y="2944368"/>
+            <a:ext cx="2505456" cy="329184"/>
           </a:xfrm>
           <a:prstGeom prst="rect">
             <a:avLst/>
@@ -6177,8 +6177,8 @@
         </p:nvSpPr>
         <p:spPr>
           <a:xfrm>
-            <a:off x="3575304" y="3090672"/>
-            <a:ext cx="2587752" cy="274320"/>
+            <a:off x="3502152" y="3200400"/>
+            <a:ext cx="2505456" cy="274320"/>
           </a:xfrm>
           <a:prstGeom prst="rect">
             <a:avLst/>
@@ -6217,8 +6217,8 @@
         </p:nvSpPr>
         <p:spPr>
           <a:xfrm>
-            <a:off x="6327648" y="2029968"/>
-            <a:ext cx="2587752" cy="1371600"/>
+            <a:off x="6181344" y="2103120"/>
+            <a:ext cx="2505456" cy="1417320"/>
           </a:xfrm>
           <a:prstGeom prst="roundRect">
             <a:avLst>
@@ -6265,8 +6265,8 @@
         </p:nvSpPr>
         <p:spPr>
           <a:xfrm>
-            <a:off x="7347204" y="2212848"/>
-            <a:ext cx="548640" cy="548640"/>
+            <a:off x="7150608" y="2322576"/>
+            <a:ext cx="566928" cy="566928"/>
           </a:xfrm>
           <a:prstGeom prst="ellipse">
             <a:avLst/>
@@ -6317,8 +6317,8 @@
         </p:blipFill>
         <p:spPr>
           <a:xfrm>
-            <a:off x="7478877" y="2344521"/>
-            <a:ext cx="285292" cy="285292"/>
+            <a:off x="7286670" y="2458638"/>
+            <a:ext cx="294802" cy="294802"/>
           </a:xfrm>
           <a:prstGeom prst="rect">
             <a:avLst/>
@@ -6333,8 +6333,8 @@
         </p:nvSpPr>
         <p:spPr>
           <a:xfrm>
-            <a:off x="6327648" y="2816352"/>
-            <a:ext cx="2587752" cy="329184"/>
+            <a:off x="6181344" y="2944368"/>
+            <a:ext cx="2505456" cy="329184"/>
           </a:xfrm>
           <a:prstGeom prst="rect">
             <a:avLst/>
@@ -6373,8 +6373,8 @@
         </p:nvSpPr>
         <p:spPr>
           <a:xfrm>
-            <a:off x="6327648" y="3090672"/>
-            <a:ext cx="2587752" cy="274320"/>
+            <a:off x="6181344" y="3200400"/>
+            <a:ext cx="2505456" cy="274320"/>
           </a:xfrm>
           <a:prstGeom prst="rect">
             <a:avLst/>
@@ -6413,8 +6413,8 @@
         </p:nvSpPr>
         <p:spPr>
           <a:xfrm>
-            <a:off x="9079992" y="2029968"/>
-            <a:ext cx="2587752" cy="1371600"/>
+            <a:off x="8860536" y="2103120"/>
+            <a:ext cx="2505456" cy="1417320"/>
           </a:xfrm>
           <a:prstGeom prst="roundRect">
             <a:avLst>
@@ -6461,8 +6461,8 @@
         </p:nvSpPr>
         <p:spPr>
           <a:xfrm>
-            <a:off x="10099548" y="2212848"/>
-            <a:ext cx="548640" cy="548640"/>
+            <a:off x="9829800" y="2322576"/>
+            <a:ext cx="566928" cy="566928"/>
           </a:xfrm>
           <a:prstGeom prst="ellipse">
             <a:avLst/>
@@ -6513,8 +6513,8 @@
         </p:blipFill>
         <p:spPr>
           <a:xfrm>
-            <a:off x="10231221" y="2344521"/>
-            <a:ext cx="285292" cy="285292"/>
+            <a:off x="9965862" y="2458638"/>
+            <a:ext cx="294802" cy="294802"/>
           </a:xfrm>
           <a:prstGeom prst="rect">
             <a:avLst/>
@@ -6529,8 +6529,8 @@
         </p:nvSpPr>
         <p:spPr>
           <a:xfrm>
-            <a:off x="9079992" y="2816352"/>
-            <a:ext cx="2587752" cy="329184"/>
+            <a:off x="8860536" y="2944368"/>
+            <a:ext cx="2505456" cy="329184"/>
           </a:xfrm>
           <a:prstGeom prst="rect">
             <a:avLst/>
@@ -6569,8 +6569,8 @@
         </p:nvSpPr>
         <p:spPr>
           <a:xfrm>
-            <a:off x="9079992" y="3090672"/>
-            <a:ext cx="2587752" cy="274320"/>
+            <a:off x="8860536" y="3200400"/>
+            <a:ext cx="2505456" cy="274320"/>
           </a:xfrm>
           <a:prstGeom prst="rect">
             <a:avLst/>
@@ -6609,12 +6609,12 @@
         </p:nvSpPr>
         <p:spPr>
           <a:xfrm>
-            <a:off x="822960" y="3566160"/>
-            <a:ext cx="10543032" cy="548640"/>
+            <a:off x="822960" y="3703320"/>
+            <a:ext cx="10543032" cy="914400"/>
           </a:xfrm>
           <a:prstGeom prst="roundRect">
             <a:avLst>
-              <a:gd name="adj" fmla="val 12000"/>
+              <a:gd name="adj" fmla="val 6000"/>
             </a:avLst>
           </a:prstGeom>
           <a:solidFill>
@@ -6657,8 +6657,8 @@
         </p:nvSpPr>
         <p:spPr>
           <a:xfrm>
-            <a:off x="1060704" y="3657600"/>
-            <a:ext cx="365760" cy="365760"/>
+            <a:off x="1060704" y="3950208"/>
+            <a:ext cx="420624" cy="420624"/>
           </a:xfrm>
           <a:prstGeom prst="ellipse">
             <a:avLst/>
@@ -6709,8 +6709,8 @@
         </p:blipFill>
         <p:spPr>
           <a:xfrm>
-            <a:off x="1148486" y="3745382"/>
-            <a:ext cx="190195" cy="190195"/>
+            <a:off x="1161653" y="4051157"/>
+            <a:ext cx="218724" cy="218724"/>
           </a:xfrm>
           <a:prstGeom prst="rect">
             <a:avLst/>
@@ -6725,8 +6725,8 @@
         </p:nvSpPr>
         <p:spPr>
           <a:xfrm>
-            <a:off x="1591056" y="3566160"/>
-            <a:ext cx="9601200" cy="548640"/>
+            <a:off x="1645920" y="3831335"/>
+            <a:ext cx="4572000" cy="658368"/>
           </a:xfrm>
           <a:prstGeom prst="rect">
             <a:avLst/>
@@ -6742,18 +6742,28 @@
                 <a:spcPts val="0"/>
               </a:spcBef>
               <a:spcAft>
-                <a:spcPts val="0"/>
+                <a:spcPts val="300"/>
               </a:spcAft>
             </a:pPr>
             <a:r>
-              <a:rPr sz="1150" b="1" i="0">
+              <a:rPr sz="1100" b="1" i="0" spc="40">
                 <a:solidFill>
                   <a:srgbClr val="12B3C4"/>
                 </a:solidFill>
                 <a:latin typeface="Aptos"/>
               </a:rPr>
-              <a:t>Where these come from:  </a:t>
-            </a:r>
+              <a:t>ACTIVE  ·  RETURNING  ·  ASSISTED HOURS</a:t>
+            </a:r>
+          </a:p>
+          <a:p>
+            <a:pPr algn="l">
+              <a:spcBef>
+                <a:spcPts val="0"/>
+              </a:spcBef>
+              <a:spcAft>
+                <a:spcPts val="0"/>
+              </a:spcAft>
+            </a:pPr>
             <a:r>
               <a:rPr sz="1150" b="0" i="0">
                 <a:solidFill>
@@ -6761,21 +6771,192 @@
                 </a:solidFill>
                 <a:latin typeface="Aptos"/>
               </a:rPr>
-              <a:t>the Microsoft 365 Copilot Dashboard in Viva Insights, plus the Microsoft 365 admin usage reports.</a:t>
-            </a:r>
-          </a:p>
-        </p:txBody>
-      </p:sp>
-      <p:sp>
-        <p:nvSpPr>
-          <p:cNvPr id="33" name="Rounded Rectangle 32"/>
+              <a:t>Copilot Dashboard (Viva Insights) + admin usage reports</a:t>
+            </a:r>
+          </a:p>
+        </p:txBody>
+      </p:sp>
+      <p:sp>
+        <p:nvSpPr>
+          <p:cNvPr id="33" name="Rectangle 32"/>
           <p:cNvSpPr/>
           <p:nvPr/>
         </p:nvSpPr>
         <p:spPr>
           <a:xfrm>
-            <a:off x="822960" y="4315968"/>
-            <a:ext cx="10543032" cy="1024128"/>
+            <a:off x="6400800" y="3886200"/>
+            <a:ext cx="18288" cy="548640"/>
+          </a:xfrm>
+          <a:prstGeom prst="rect">
+            <a:avLst/>
+          </a:prstGeom>
+          <a:solidFill>
+            <a:srgbClr val="2C3B69"/>
+          </a:solidFill>
+          <a:ln>
+            <a:noFill/>
+          </a:ln>
+          <a:effectLst/>
+        </p:spPr>
+        <p:style>
+          <a:lnRef idx="1">
+            <a:schemeClr val="accent1"/>
+          </a:lnRef>
+          <a:fillRef idx="3">
+            <a:schemeClr val="accent1"/>
+          </a:fillRef>
+          <a:effectRef idx="2">
+            <a:schemeClr val="accent1"/>
+          </a:effectRef>
+          <a:fontRef idx="minor">
+            <a:schemeClr val="lt1"/>
+          </a:fontRef>
+        </p:style>
+        <p:txBody>
+          <a:bodyPr rtlCol="0" anchor="ctr"/>
+          <a:lstStyle/>
+          <a:p>
+            <a:pPr algn="ctr"/>
+          </a:p>
+        </p:txBody>
+      </p:sp>
+      <p:sp>
+        <p:nvSpPr>
+          <p:cNvPr id="34" name="Oval 33"/>
+          <p:cNvSpPr/>
+          <p:nvPr/>
+        </p:nvSpPr>
+        <p:spPr>
+          <a:xfrm>
+            <a:off x="6601968" y="3950208"/>
+            <a:ext cx="420624" cy="420624"/>
+          </a:xfrm>
+          <a:prstGeom prst="ellipse">
+            <a:avLst/>
+          </a:prstGeom>
+          <a:solidFill>
+            <a:srgbClr val="F0A500"/>
+          </a:solidFill>
+          <a:ln>
+            <a:noFill/>
+          </a:ln>
+          <a:effectLst/>
+        </p:spPr>
+        <p:style>
+          <a:lnRef idx="1">
+            <a:schemeClr val="accent1"/>
+          </a:lnRef>
+          <a:fillRef idx="3">
+            <a:schemeClr val="accent1"/>
+          </a:fillRef>
+          <a:effectRef idx="2">
+            <a:schemeClr val="accent1"/>
+          </a:effectRef>
+          <a:fontRef idx="minor">
+            <a:schemeClr val="lt1"/>
+          </a:fontRef>
+        </p:style>
+        <p:txBody>
+          <a:bodyPr rtlCol="0" anchor="ctr"/>
+          <a:lstStyle/>
+          <a:p>
+            <a:pPr algn="ctr"/>
+          </a:p>
+        </p:txBody>
+      </p:sp>
+      <p:pic>
+        <p:nvPicPr>
+          <p:cNvPr id="35" name="Picture 34" descr="star.png"/>
+          <p:cNvPicPr>
+            <a:picLocks noChangeAspect="1"/>
+          </p:cNvPicPr>
+          <p:nvPr/>
+        </p:nvPicPr>
+        <p:blipFill>
+          <a:blip r:embed="rId5"/>
+          <a:stretch>
+            <a:fillRect/>
+          </a:stretch>
+        </p:blipFill>
+        <p:spPr>
+          <a:xfrm>
+            <a:off x="6702917" y="4051157"/>
+            <a:ext cx="218724" cy="218724"/>
+          </a:xfrm>
+          <a:prstGeom prst="rect">
+            <a:avLst/>
+          </a:prstGeom>
+        </p:spPr>
+      </p:pic>
+      <p:sp>
+        <p:nvSpPr>
+          <p:cNvPr id="36" name="TextBox 35"/>
+          <p:cNvSpPr txBox="1"/>
+          <p:nvPr/>
+        </p:nvSpPr>
+        <p:spPr>
+          <a:xfrm>
+            <a:off x="7187184" y="3831335"/>
+            <a:ext cx="4114800" cy="658368"/>
+          </a:xfrm>
+          <a:prstGeom prst="rect">
+            <a:avLst/>
+          </a:prstGeom>
+          <a:noFill/>
+        </p:spPr>
+        <p:txBody>
+          <a:bodyPr wrap="square" anchor="ctr" lIns="0" rIns="0" tIns="0" bIns="0"/>
+          <a:lstStyle/>
+          <a:p>
+            <a:pPr algn="l">
+              <a:spcBef>
+                <a:spcPts val="0"/>
+              </a:spcBef>
+              <a:spcAft>
+                <a:spcPts val="300"/>
+              </a:spcAft>
+            </a:pPr>
+            <a:r>
+              <a:rPr sz="1100" b="1" i="0" spc="40">
+                <a:solidFill>
+                  <a:srgbClr val="F0A500"/>
+                </a:solidFill>
+                <a:latin typeface="Aptos"/>
+              </a:rPr>
+              <a:t>SATISFACTION</a:t>
+            </a:r>
+          </a:p>
+          <a:p>
+            <a:pPr algn="l">
+              <a:spcBef>
+                <a:spcPts val="0"/>
+              </a:spcBef>
+              <a:spcAft>
+                <a:spcPts val="0"/>
+              </a:spcAft>
+            </a:pPr>
+            <a:r>
+              <a:rPr sz="1150" b="0" i="0">
+                <a:solidFill>
+                  <a:srgbClr val="D7E0F5"/>
+                </a:solidFill>
+                <a:latin typeface="Aptos"/>
+              </a:rPr>
+              <a:t>A short pulse survey (Viva Pulse or a form)</a:t>
+            </a:r>
+          </a:p>
+        </p:txBody>
+      </p:sp>
+      <p:sp>
+        <p:nvSpPr>
+          <p:cNvPr id="37" name="Rounded Rectangle 36"/>
+          <p:cNvSpPr/>
+          <p:nvPr/>
+        </p:nvSpPr>
+        <p:spPr>
+          <a:xfrm>
+            <a:off x="822960" y="4800600"/>
+            <a:ext cx="10543032" cy="1078992"/>
           </a:xfrm>
           <a:prstGeom prst="roundRect">
             <a:avLst>
@@ -6816,14 +6997,14 @@
       </p:sp>
       <p:sp>
         <p:nvSpPr>
-          <p:cNvPr id="34" name="TextBox 33"/>
+          <p:cNvPr id="38" name="TextBox 37"/>
           <p:cNvSpPr txBox="1"/>
           <p:nvPr/>
         </p:nvSpPr>
         <p:spPr>
           <a:xfrm>
-            <a:off x="914400" y="4315968"/>
-            <a:ext cx="2651760" cy="1024128"/>
+            <a:off x="914400" y="4800600"/>
+            <a:ext cx="2651760" cy="1078992"/>
           </a:xfrm>
           <a:prstGeom prst="rect">
             <a:avLst/>
@@ -6843,7 +7024,7 @@
               </a:spcAft>
             </a:pPr>
             <a:r>
-              <a:rPr sz="2600" b="1" i="0">
+              <a:rPr sz="2500" b="1" i="0">
                 <a:solidFill>
                   <a:srgbClr val="F0A500"/>
                 </a:solidFill>
@@ -6875,14 +7056,14 @@
       </p:sp>
       <p:sp>
         <p:nvSpPr>
-          <p:cNvPr id="35" name="Rectangle 34"/>
+          <p:cNvPr id="39" name="Rectangle 38"/>
           <p:cNvSpPr/>
           <p:nvPr/>
         </p:nvSpPr>
         <p:spPr>
           <a:xfrm>
-            <a:off x="3657600" y="4535424"/>
-            <a:ext cx="18288" cy="585216"/>
+            <a:off x="3657600" y="5047488"/>
+            <a:ext cx="18288" cy="585215"/>
           </a:xfrm>
           <a:prstGeom prst="rect">
             <a:avLst/>
@@ -6919,14 +7100,14 @@
       </p:sp>
       <p:sp>
         <p:nvSpPr>
-          <p:cNvPr id="36" name="TextBox 35"/>
+          <p:cNvPr id="40" name="TextBox 39"/>
           <p:cNvSpPr txBox="1"/>
           <p:nvPr/>
         </p:nvSpPr>
         <p:spPr>
           <a:xfrm>
-            <a:off x="3886200" y="4315968"/>
-            <a:ext cx="7269480" cy="1024128"/>
+            <a:off x="3886200" y="4800600"/>
+            <a:ext cx="7269480" cy="1078992"/>
           </a:xfrm>
           <a:prstGeom prst="rect">
             <a:avLst/>
@@ -6946,7 +7127,7 @@
               </a:spcAft>
             </a:pPr>
             <a:r>
-              <a:rPr sz="1400" b="1" i="0">
+              <a:rPr sz="1350" b="1" i="0">
                 <a:solidFill>
                   <a:srgbClr val="FFFFFF"/>
                 </a:solidFill>
@@ -6955,7 +7136,7 @@
               <a:t>The tipping point:  </a:t>
             </a:r>
             <a:r>
-              <a:rPr sz="1400" b="0" i="0">
+              <a:rPr sz="1350" b="0" i="0">
                 <a:solidFill>
                   <a:srgbClr val="9FB0D8"/>
                 </a:solidFill>
@@ -6968,62 +7149,14 @@
       </p:sp>
       <p:sp>
         <p:nvSpPr>
-          <p:cNvPr id="37" name="Rounded Rectangle 36"/>
-          <p:cNvSpPr/>
-          <p:nvPr/>
-        </p:nvSpPr>
-        <p:spPr>
-          <a:xfrm>
-            <a:off x="822960" y="5541264"/>
-            <a:ext cx="10543032" cy="512064"/>
-          </a:xfrm>
-          <a:prstGeom prst="roundRect">
-            <a:avLst>
-              <a:gd name="adj" fmla="val 16000"/>
-            </a:avLst>
-          </a:prstGeom>
-          <a:solidFill>
-            <a:srgbClr val="1B2A55"/>
-          </a:solidFill>
-          <a:ln w="12700">
-            <a:solidFill>
-              <a:srgbClr val="2C3B69"/>
-            </a:solidFill>
-          </a:ln>
-          <a:effectLst/>
-        </p:spPr>
-        <p:style>
-          <a:lnRef idx="1">
-            <a:schemeClr val="accent1"/>
-          </a:lnRef>
-          <a:fillRef idx="3">
-            <a:schemeClr val="accent1"/>
-          </a:fillRef>
-          <a:effectRef idx="2">
-            <a:schemeClr val="accent1"/>
-          </a:effectRef>
-          <a:fontRef idx="minor">
-            <a:schemeClr val="lt1"/>
-          </a:fontRef>
-        </p:style>
-        <p:txBody>
-          <a:bodyPr rtlCol="0" anchor="ctr"/>
-          <a:lstStyle/>
-          <a:p>
-            <a:pPr algn="ctr"/>
-          </a:p>
-        </p:txBody>
-      </p:sp>
-      <p:sp>
-        <p:nvSpPr>
-          <p:cNvPr id="38" name="TextBox 37"/>
+          <p:cNvPr id="41" name="TextBox 40"/>
           <p:cNvSpPr txBox="1"/>
           <p:nvPr/>
         </p:nvSpPr>
         <p:spPr>
           <a:xfrm>
-            <a:off x="1115568" y="5541264"/>
-            <a:ext cx="9994392" cy="512064"/>
+            <a:off x="640080" y="6446520"/>
+            <a:ext cx="7315200" cy="274320"/>
           </a:xfrm>
           <a:prstGeom prst="rect">
             <a:avLst/>
@@ -7043,55 +7176,6 @@
               </a:spcAft>
             </a:pPr>
             <a:r>
-              <a:rPr sz="1400" b="1" i="0">
-                <a:solidFill>
-                  <a:srgbClr val="F0A500"/>
-                </a:solidFill>
-                <a:latin typeface="Consolas"/>
-              </a:rPr>
-              <a:t>›_  </a:t>
-            </a:r>
-            <a:r>
-              <a:rPr sz="1350" b="0" i="1">
-                <a:solidFill>
-                  <a:srgbClr val="D7E0F5"/>
-                </a:solidFill>
-                <a:latin typeface="Consolas"/>
-              </a:rPr>
-              <a:t>Watch the returning users, not the sign-ups. The habit is the ROI.</a:t>
-            </a:r>
-          </a:p>
-        </p:txBody>
-      </p:sp>
-      <p:sp>
-        <p:nvSpPr>
-          <p:cNvPr id="39" name="TextBox 38"/>
-          <p:cNvSpPr txBox="1"/>
-          <p:nvPr/>
-        </p:nvSpPr>
-        <p:spPr>
-          <a:xfrm>
-            <a:off x="640080" y="6446520"/>
-            <a:ext cx="7315200" cy="274320"/>
-          </a:xfrm>
-          <a:prstGeom prst="rect">
-            <a:avLst/>
-          </a:prstGeom>
-          <a:noFill/>
-        </p:spPr>
-        <p:txBody>
-          <a:bodyPr wrap="square" anchor="ctr" lIns="0" rIns="0" tIns="0" bIns="0"/>
-          <a:lstStyle/>
-          <a:p>
-            <a:pPr algn="l">
-              <a:spcBef>
-                <a:spcPts val="0"/>
-              </a:spcBef>
-              <a:spcAft>
-                <a:spcPts val="0"/>
-              </a:spcAft>
-            </a:pPr>
-            <a:r>
               <a:rPr sz="900" b="0" i="0">
                 <a:solidFill>
                   <a:srgbClr val="9FB0D8"/>
@@ -7114,7 +7198,7 @@
       </p:sp>
       <p:sp>
         <p:nvSpPr>
-          <p:cNvPr id="40" name="TextBox 39"/>
+          <p:cNvPr id="42" name="TextBox 41"/>
           <p:cNvSpPr txBox="1"/>
           <p:nvPr/>
         </p:nvSpPr>

</xml_diff>